<commit_message>
Slide: add talk track as speaker notes
Co-Authored-By: Claude Opus 5.5 (1M context) <noreply@anthropic.com>
</commit_message>
<xml_diff>
--- a/docs/slides/output-quality-demo-intro.pptx
+++ b/docs/slides/output-quality-demo-intro.pptx
@@ -105,6 +105,462 @@
     </a:lvl9pPr>
   </p:defaultTextStyle>
 </p:presentation>
+</file>
+
+<file path=ppt/notesMasters/notesMaster1.xml><?xml version="1.0" encoding="utf-8"?>
+<p:notesMaster xmlns:a="http://schemas.openxmlformats.org/drawingml/2006/main" xmlns:p="http://schemas.openxmlformats.org/presentationml/2006/main" xmlns:r="http://schemas.openxmlformats.org/officeDocument/2006/relationships">
+  <p:cSld>
+    <p:bg>
+      <p:bgRef idx="1001">
+        <a:schemeClr val="bg1"/>
+      </p:bgRef>
+    </p:bg>
+    <p:spTree>
+      <p:nvGrpSpPr>
+        <p:cNvPr id="1" name=""/>
+        <p:cNvGrpSpPr/>
+        <p:nvPr/>
+      </p:nvGrpSpPr>
+      <p:grpSpPr>
+        <a:xfrm>
+          <a:off x="0" y="0"/>
+          <a:ext cx="0" cy="0"/>
+          <a:chOff x="0" y="0"/>
+          <a:chExt cx="0" cy="0"/>
+        </a:xfrm>
+      </p:grpSpPr>
+      <p:sp>
+        <p:nvSpPr>
+          <p:cNvPr id="2" name="Header Placeholder 1"/>
+          <p:cNvSpPr>
+            <a:spLocks noGrp="1"/>
+          </p:cNvSpPr>
+          <p:nvPr>
+            <p:ph type="hdr" sz="quarter"/>
+          </p:nvPr>
+        </p:nvSpPr>
+        <p:spPr>
+          <a:xfrm>
+            <a:off x="0" y="0"/>
+            <a:ext cx="2971800" cy="457200"/>
+          </a:xfrm>
+          <a:prstGeom prst="rect">
+            <a:avLst/>
+          </a:prstGeom>
+        </p:spPr>
+        <p:txBody>
+          <a:bodyPr vert="horz" lIns="91440" tIns="45720" rIns="91440" bIns="45720" rtlCol="0"/>
+          <a:lstStyle>
+            <a:lvl1pPr algn="l">
+              <a:defRPr sz="1200"/>
+            </a:lvl1pPr>
+          </a:lstStyle>
+          <a:p>
+            <a:endParaRPr lang="en-US"/>
+          </a:p>
+        </p:txBody>
+      </p:sp>
+      <p:sp>
+        <p:nvSpPr>
+          <p:cNvPr id="3" name="Date Placeholder 2"/>
+          <p:cNvSpPr>
+            <a:spLocks noGrp="1"/>
+          </p:cNvSpPr>
+          <p:nvPr>
+            <p:ph type="dt" idx="1"/>
+          </p:nvPr>
+        </p:nvSpPr>
+        <p:spPr>
+          <a:xfrm>
+            <a:off x="3884613" y="0"/>
+            <a:ext cx="2971800" cy="457200"/>
+          </a:xfrm>
+          <a:prstGeom prst="rect">
+            <a:avLst/>
+          </a:prstGeom>
+        </p:spPr>
+        <p:txBody>
+          <a:bodyPr vert="horz" lIns="91440" tIns="45720" rIns="91440" bIns="45720" rtlCol="0"/>
+          <a:lstStyle>
+            <a:lvl1pPr algn="r">
+              <a:defRPr sz="1200"/>
+            </a:lvl1pPr>
+          </a:lstStyle>
+          <a:p>
+            <a:fld id="{0F89C1C7-3DCD-1040-A9CF-14679D8B5DDD}" type="datetimeFigureOut">
+              <a:rPr lang="en-US" smtClean="0"/>
+              <a:t>10/17/16</a:t>
+            </a:fld>
+            <a:endParaRPr lang="en-US"/>
+          </a:p>
+        </p:txBody>
+      </p:sp>
+      <p:sp>
+        <p:nvSpPr>
+          <p:cNvPr id="4" name="Slide Image Placeholder 3"/>
+          <p:cNvSpPr>
+            <a:spLocks noGrp="1" noRot="1" noChangeAspect="1"/>
+          </p:cNvSpPr>
+          <p:nvPr>
+            <p:ph type="sldImg" idx="2"/>
+          </p:nvPr>
+        </p:nvSpPr>
+        <p:spPr>
+          <a:xfrm>
+            <a:off x="1143000" y="685800"/>
+            <a:ext cx="4572000" cy="3429000"/>
+          </a:xfrm>
+          <a:prstGeom prst="rect">
+            <a:avLst/>
+          </a:prstGeom>
+          <a:noFill/>
+          <a:ln w="12700">
+            <a:solidFill>
+              <a:prstClr val="black"/>
+            </a:solidFill>
+          </a:ln>
+        </p:spPr>
+        <p:txBody>
+          <a:bodyPr vert="horz" lIns="91440" tIns="45720" rIns="91440" bIns="45720" rtlCol="0" anchor="ctr"/>
+          <a:lstStyle/>
+          <a:p>
+            <a:endParaRPr lang="en-US"/>
+          </a:p>
+        </p:txBody>
+      </p:sp>
+      <p:sp>
+        <p:nvSpPr>
+          <p:cNvPr id="5" name="Notes Placeholder 4"/>
+          <p:cNvSpPr>
+            <a:spLocks noGrp="1"/>
+          </p:cNvSpPr>
+          <p:nvPr>
+            <p:ph type="body" sz="quarter" idx="3"/>
+          </p:nvPr>
+        </p:nvSpPr>
+        <p:spPr>
+          <a:xfrm>
+            <a:off x="685800" y="4343400"/>
+            <a:ext cx="5486400" cy="4114800"/>
+          </a:xfrm>
+          <a:prstGeom prst="rect">
+            <a:avLst/>
+          </a:prstGeom>
+        </p:spPr>
+        <p:txBody>
+          <a:bodyPr vert="horz" lIns="91440" tIns="45720" rIns="91440" bIns="45720" rtlCol="0"/>
+          <a:lstStyle/>
+          <a:p>
+            <a:pPr lvl="0"/>
+            <a:r>
+              <a:rPr lang="en-US" smtClean="0"/>
+              <a:t>Click to edit Master text styles</a:t>
+            </a:r>
+          </a:p>
+          <a:p>
+            <a:pPr lvl="1"/>
+            <a:r>
+              <a:rPr lang="en-US" smtClean="0"/>
+              <a:t>Second level</a:t>
+            </a:r>
+          </a:p>
+          <a:p>
+            <a:pPr lvl="2"/>
+            <a:r>
+              <a:rPr lang="en-US" smtClean="0"/>
+              <a:t>Third level</a:t>
+            </a:r>
+          </a:p>
+          <a:p>
+            <a:pPr lvl="3"/>
+            <a:r>
+              <a:rPr lang="en-US" smtClean="0"/>
+              <a:t>Fourth level</a:t>
+            </a:r>
+          </a:p>
+          <a:p>
+            <a:pPr lvl="4"/>
+            <a:r>
+              <a:rPr lang="en-US" smtClean="0"/>
+              <a:t>Fifth level</a:t>
+            </a:r>
+            <a:endParaRPr lang="en-US"/>
+          </a:p>
+        </p:txBody>
+      </p:sp>
+      <p:sp>
+        <p:nvSpPr>
+          <p:cNvPr id="6" name="Footer Placeholder 5"/>
+          <p:cNvSpPr>
+            <a:spLocks noGrp="1"/>
+          </p:cNvSpPr>
+          <p:nvPr>
+            <p:ph type="ftr" sz="quarter" idx="4"/>
+          </p:nvPr>
+        </p:nvSpPr>
+        <p:spPr>
+          <a:xfrm>
+            <a:off x="0" y="8685213"/>
+            <a:ext cx="2971800" cy="457200"/>
+          </a:xfrm>
+          <a:prstGeom prst="rect">
+            <a:avLst/>
+          </a:prstGeom>
+        </p:spPr>
+        <p:txBody>
+          <a:bodyPr vert="horz" lIns="91440" tIns="45720" rIns="91440" bIns="45720" rtlCol="0" anchor="b"/>
+          <a:lstStyle>
+            <a:lvl1pPr algn="l">
+              <a:defRPr sz="1200"/>
+            </a:lvl1pPr>
+          </a:lstStyle>
+          <a:p>
+            <a:endParaRPr lang="en-US"/>
+          </a:p>
+        </p:txBody>
+      </p:sp>
+      <p:sp>
+        <p:nvSpPr>
+          <p:cNvPr id="7" name="Slide Number Placeholder 6"/>
+          <p:cNvSpPr>
+            <a:spLocks noGrp="1"/>
+          </p:cNvSpPr>
+          <p:nvPr>
+            <p:ph type="sldNum" sz="quarter" idx="5"/>
+          </p:nvPr>
+        </p:nvSpPr>
+        <p:spPr>
+          <a:xfrm>
+            <a:off x="3884613" y="8685213"/>
+            <a:ext cx="2971800" cy="457200"/>
+          </a:xfrm>
+          <a:prstGeom prst="rect">
+            <a:avLst/>
+          </a:prstGeom>
+        </p:spPr>
+        <p:txBody>
+          <a:bodyPr vert="horz" lIns="91440" tIns="45720" rIns="91440" bIns="45720" rtlCol="0" anchor="b"/>
+          <a:lstStyle>
+            <a:lvl1pPr algn="r">
+              <a:defRPr sz="1200"/>
+            </a:lvl1pPr>
+          </a:lstStyle>
+          <a:p>
+            <a:fld id="{BB5E49A5-4136-284D-997B-48E1D791AD67}" type="slidenum">
+              <a:rPr lang="en-US" smtClean="0"/>
+              <a:t>‹#›</a:t>
+            </a:fld>
+            <a:endParaRPr lang="en-US"/>
+          </a:p>
+        </p:txBody>
+      </p:sp>
+    </p:spTree>
+    <p:extLst>
+      <p:ext uri="{BB962C8B-B14F-4D97-AF65-F5344CB8AC3E}">
+        <p14:creationId xmlns:p14="http://schemas.microsoft.com/office/powerpoint/2010/main" val="2623252185"/>
+      </p:ext>
+    </p:extLst>
+  </p:cSld>
+  <p:clrMap bg1="lt1" tx1="dk1" bg2="lt2" tx2="dk2" accent1="accent1" accent2="accent2" accent3="accent3" accent4="accent4" accent5="accent5" accent6="accent6" hlink="hlink" folHlink="folHlink"/>
+  <p:notesStyle>
+    <a:lvl1pPr marL="0" algn="l" defTabSz="457200" rtl="0" eaLnBrk="1" latinLnBrk="0" hangingPunct="1">
+      <a:defRPr sz="1200" kern="1200">
+        <a:solidFill>
+          <a:schemeClr val="tx1"/>
+        </a:solidFill>
+        <a:latin typeface="+mn-lt"/>
+        <a:ea typeface="+mn-ea"/>
+        <a:cs typeface="+mn-cs"/>
+      </a:defRPr>
+    </a:lvl1pPr>
+    <a:lvl2pPr marL="457200" algn="l" defTabSz="457200" rtl="0" eaLnBrk="1" latinLnBrk="0" hangingPunct="1">
+      <a:defRPr sz="1200" kern="1200">
+        <a:solidFill>
+          <a:schemeClr val="tx1"/>
+        </a:solidFill>
+        <a:latin typeface="+mn-lt"/>
+        <a:ea typeface="+mn-ea"/>
+        <a:cs typeface="+mn-cs"/>
+      </a:defRPr>
+    </a:lvl2pPr>
+    <a:lvl3pPr marL="914400" algn="l" defTabSz="457200" rtl="0" eaLnBrk="1" latinLnBrk="0" hangingPunct="1">
+      <a:defRPr sz="1200" kern="1200">
+        <a:solidFill>
+          <a:schemeClr val="tx1"/>
+        </a:solidFill>
+        <a:latin typeface="+mn-lt"/>
+        <a:ea typeface="+mn-ea"/>
+        <a:cs typeface="+mn-cs"/>
+      </a:defRPr>
+    </a:lvl3pPr>
+    <a:lvl4pPr marL="1371600" algn="l" defTabSz="457200" rtl="0" eaLnBrk="1" latinLnBrk="0" hangingPunct="1">
+      <a:defRPr sz="1200" kern="1200">
+        <a:solidFill>
+          <a:schemeClr val="tx1"/>
+        </a:solidFill>
+        <a:latin typeface="+mn-lt"/>
+        <a:ea typeface="+mn-ea"/>
+        <a:cs typeface="+mn-cs"/>
+      </a:defRPr>
+    </a:lvl4pPr>
+    <a:lvl5pPr marL="1828800" algn="l" defTabSz="457200" rtl="0" eaLnBrk="1" latinLnBrk="0" hangingPunct="1">
+      <a:defRPr sz="1200" kern="1200">
+        <a:solidFill>
+          <a:schemeClr val="tx1"/>
+        </a:solidFill>
+        <a:latin typeface="+mn-lt"/>
+        <a:ea typeface="+mn-ea"/>
+        <a:cs typeface="+mn-cs"/>
+      </a:defRPr>
+    </a:lvl5pPr>
+    <a:lvl6pPr marL="2286000" algn="l" defTabSz="457200" rtl="0" eaLnBrk="1" latinLnBrk="0" hangingPunct="1">
+      <a:defRPr sz="1200" kern="1200">
+        <a:solidFill>
+          <a:schemeClr val="tx1"/>
+        </a:solidFill>
+        <a:latin typeface="+mn-lt"/>
+        <a:ea typeface="+mn-ea"/>
+        <a:cs typeface="+mn-cs"/>
+      </a:defRPr>
+    </a:lvl6pPr>
+    <a:lvl7pPr marL="2743200" algn="l" defTabSz="457200" rtl="0" eaLnBrk="1" latinLnBrk="0" hangingPunct="1">
+      <a:defRPr sz="1200" kern="1200">
+        <a:solidFill>
+          <a:schemeClr val="tx1"/>
+        </a:solidFill>
+        <a:latin typeface="+mn-lt"/>
+        <a:ea typeface="+mn-ea"/>
+        <a:cs typeface="+mn-cs"/>
+      </a:defRPr>
+    </a:lvl7pPr>
+    <a:lvl8pPr marL="3200400" algn="l" defTabSz="457200" rtl="0" eaLnBrk="1" latinLnBrk="0" hangingPunct="1">
+      <a:defRPr sz="1200" kern="1200">
+        <a:solidFill>
+          <a:schemeClr val="tx1"/>
+        </a:solidFill>
+        <a:latin typeface="+mn-lt"/>
+        <a:ea typeface="+mn-ea"/>
+        <a:cs typeface="+mn-cs"/>
+      </a:defRPr>
+    </a:lvl8pPr>
+    <a:lvl9pPr marL="3657600" algn="l" defTabSz="457200" rtl="0" eaLnBrk="1" latinLnBrk="0" hangingPunct="1">
+      <a:defRPr sz="1200" kern="1200">
+        <a:solidFill>
+          <a:schemeClr val="tx1"/>
+        </a:solidFill>
+        <a:latin typeface="+mn-lt"/>
+        <a:ea typeface="+mn-ea"/>
+        <a:cs typeface="+mn-cs"/>
+      </a:defRPr>
+    </a:lvl9pPr>
+  </p:notesStyle>
+</p:notesMaster>
+</file>
+
+<file path=ppt/notesSlides/notesSlide1.xml><?xml version="1.0" encoding="utf-8"?>
+<p:notes xmlns:a="http://schemas.openxmlformats.org/drawingml/2006/main" xmlns:p="http://schemas.openxmlformats.org/presentationml/2006/main" xmlns:r="http://schemas.openxmlformats.org/officeDocument/2006/relationships">
+  <p:cSld>
+    <p:spTree>
+      <p:nvGrpSpPr>
+        <p:cNvPr id="1" name=""/>
+        <p:cNvGrpSpPr/>
+        <p:nvPr/>
+      </p:nvGrpSpPr>
+      <p:grpSpPr>
+        <a:xfrm>
+          <a:off x="0" y="0"/>
+          <a:ext cx="0" cy="0"/>
+          <a:chOff x="0" y="0"/>
+          <a:chExt cx="0" cy="0"/>
+        </a:xfrm>
+      </p:grpSpPr>
+      <p:sp>
+        <p:nvSpPr>
+          <p:cNvPr id="2" name="Slide Image Placeholder 1"/>
+          <p:cNvSpPr>
+            <a:spLocks noGrp="1"/>
+          </p:cNvSpPr>
+          <p:nvPr>
+            <p:ph type="sldImg" idx="2"/>
+          </p:nvPr>
+        </p:nvSpPr>
+        <p:spPr/>
+      </p:sp>
+      <p:sp>
+        <p:nvSpPr>
+          <p:cNvPr id="3" name="Notes Placeholder 2"/>
+          <p:cNvSpPr>
+            <a:spLocks noGrp="1"/>
+          </p:cNvSpPr>
+          <p:nvPr>
+            <p:ph type="body" idx="3" sz="quarter"/>
+          </p:nvPr>
+        </p:nvSpPr>
+        <p:spPr/>
+        <p:txBody>
+          <a:bodyPr/>
+          <a:lstStyle/>
+          <a:p>
+            <a:r>
+              <a:t>OPENING — AI agents now answer users directly. Most guardrails look at what goes INTO the model (the prompt); very few check what comes OUT. Was the answer true? Fair? On topic? This policy checks every answer on the gateway, before it reaches the user, with no change to the agent.</a:t>
+            </a:r>
+          </a:p>
+          <a:p/>
+          <a:p>
+            <a:r>
+              <a:t>01 WHERE IT RUNS — Omni Gateway, as an outbound policy: between the gateway and the agent, so it sees exactly what the agent sent back. For each reply the gateway asks a separate AI (OpenAI gpt-5.4) to judge it. The agent uses a smaller model, so it's never marking its own homework.</a:t>
+            </a:r>
+          </a:p>
+          <a:p/>
+          <a:p>
+            <a:r>
+              <a:t>02 HOW IT DECIDES — Three layers. (1) The LLM judge reads the user's question and the answer and scores 0-1 for hallucination, toxicity, bias and anomaly (off-topic, leaked instructions). (2) If the judge is slow or down, a backup checklist of red-flag words takes over; cruder, but traffic never waits. (3) Always-on checks: empty, cut-off or looping answers, failed tasks, and users' thumbs-down; if many users complain, every answer gets flagged.</a:t>
+            </a:r>
+          </a:p>
+          <a:p/>
+          <a:p>
+            <a:r>
+              <a:t>03 WHAT IT DOES — Your choice per risk: PASS clean answers, ANNOTATE (deliver with a quality report the app can use to warn the user), or BLOCK (withhold the answer). Start by monitoring, tighten one category at a time. Every flag is logged by the gateway and reported in the response.</a:t>
+            </a:r>
+          </a:p>
+          <a:p/>
+          <a:p>
+            <a:r>
+              <a:t>NUMBERS — Live run on CloudHub 2.0: 1-2.5 s per verdict, 4 risk categories, A2A v0.3 and v1.0 plus OpenAI/Anthropic-style APIs, 102 automated tests.</a:t>
+            </a:r>
+          </a:p>
+          <a:p/>
+          <a:p>
+            <a:r>
+              <a:t>TRANSITION — Honesty note: the bad answers in the demo are scripted (today's models won't misbehave on cue). The judge is real, and so is every verdict. Let's look.</a:t>
+            </a:r>
+          </a:p>
+          <a:p/>
+          <a:p>
+            <a:r>
+              <a:t>IF ASKED — Monitoring: request volume and latency yes; flags are in gateway logs and the response report, outbound violation counts aren't in Monitoring yet. LLM traffic: the policy reads OpenAI and Anthropic formats; the live demo uses an A2A agent, the LLM-API path is lab-tested. Latency: ~1-2.5 s with the judge on every answer; near zero for clean traffic with judgeMode onSuspicion.</a:t>
+            </a:r>
+          </a:p>
+        </p:txBody>
+      </p:sp>
+      <p:sp>
+        <p:nvSpPr>
+          <p:cNvPr id="4" name="Slide Number Placeholder 3"/>
+          <p:cNvSpPr>
+            <a:spLocks noGrp="1"/>
+          </p:cNvSpPr>
+          <p:nvPr>
+            <p:ph type="sldNum" idx="5" sz="quarter"/>
+          </p:nvPr>
+        </p:nvSpPr>
+        <p:spPr/>
+      </p:sp>
+    </p:spTree>
+  </p:cSld>
+  <p:clrMapOvr>
+    <a:masterClrMapping/>
+  </p:clrMapOvr>
+</p:notes>
 </file>
 
 <file path=ppt/slideLayouts/slideLayout1.xml><?xml version="1.0" encoding="utf-8"?>
@@ -5599,4 +6055,324 @@
   </a:objectDefaults>
   <a:extraClrSchemeLst/>
 </a:theme>
+</file>
+
+<file path=ppt/theme/theme2.xml><?xml version="1.0" encoding="utf-8"?>
+<a:theme xmlns:a="http://schemas.openxmlformats.org/drawingml/2006/main" name="Office Theme">
+  <a:themeElements>
+    <a:clrScheme name="Office">
+      <a:dk1>
+        <a:sysClr val="windowText" lastClr="000000"/>
+      </a:dk1>
+      <a:lt1>
+        <a:sysClr val="window" lastClr="FFFFFF"/>
+      </a:lt1>
+      <a:dk2>
+        <a:srgbClr val="1F497D"/>
+      </a:dk2>
+      <a:lt2>
+        <a:srgbClr val="EEECE1"/>
+      </a:lt2>
+      <a:accent1>
+        <a:srgbClr val="4F81BD"/>
+      </a:accent1>
+      <a:accent2>
+        <a:srgbClr val="C0504D"/>
+      </a:accent2>
+      <a:accent3>
+        <a:srgbClr val="9BBB59"/>
+      </a:accent3>
+      <a:accent4>
+        <a:srgbClr val="8064A2"/>
+      </a:accent4>
+      <a:accent5>
+        <a:srgbClr val="4BACC6"/>
+      </a:accent5>
+      <a:accent6>
+        <a:srgbClr val="F79646"/>
+      </a:accent6>
+      <a:hlink>
+        <a:srgbClr val="0000FF"/>
+      </a:hlink>
+      <a:folHlink>
+        <a:srgbClr val="800080"/>
+      </a:folHlink>
+    </a:clrScheme>
+    <a:fontScheme name="Office">
+      <a:majorFont>
+        <a:latin typeface="Calibri"/>
+        <a:ea typeface=""/>
+        <a:cs typeface=""/>
+        <a:font script="Jpan" typeface="ＭＳ Ｐゴシック"/>
+        <a:font script="Hang" typeface="맑은 고딕"/>
+        <a:font script="Hans" typeface="宋体"/>
+        <a:font script="Hant" typeface="新細明體"/>
+        <a:font script="Arab" typeface="Times New Roman"/>
+        <a:font script="Hebr" typeface="Times New Roman"/>
+        <a:font script="Thai" typeface="Angsana New"/>
+        <a:font script="Ethi" typeface="Nyala"/>
+        <a:font script="Beng" typeface="Vrinda"/>
+        <a:font script="Gujr" typeface="Shruti"/>
+        <a:font script="Khmr" typeface="MoolBoran"/>
+        <a:font script="Knda" typeface="Tunga"/>
+        <a:font script="Guru" typeface="Raavi"/>
+        <a:font script="Cans" typeface="Euphemia"/>
+        <a:font script="Cher" typeface="Plantagenet Cherokee"/>
+        <a:font script="Yiii" typeface="Microsoft Yi Baiti"/>
+        <a:font script="Tibt" typeface="Microsoft Himalaya"/>
+        <a:font script="Thaa" typeface="MV Boli"/>
+        <a:font script="Deva" typeface="Mangal"/>
+        <a:font script="Telu" typeface="Gautami"/>
+        <a:font script="Taml" typeface="Latha"/>
+        <a:font script="Syrc" typeface="Estrangelo Edessa"/>
+        <a:font script="Orya" typeface="Kalinga"/>
+        <a:font script="Mlym" typeface="Kartika"/>
+        <a:font script="Laoo" typeface="DokChampa"/>
+        <a:font script="Sinh" typeface="Iskoola Pota"/>
+        <a:font script="Mong" typeface="Mongolian Baiti"/>
+        <a:font script="Viet" typeface="Times New Roman"/>
+        <a:font script="Uigh" typeface="Microsoft Uighur"/>
+        <a:font script="Geor" typeface="Sylfaen"/>
+      </a:majorFont>
+      <a:minorFont>
+        <a:latin typeface="Calibri"/>
+        <a:ea typeface=""/>
+        <a:cs typeface=""/>
+        <a:font script="Jpan" typeface="ＭＳ Ｐゴシック"/>
+        <a:font script="Hang" typeface="맑은 고딕"/>
+        <a:font script="Hans" typeface="宋体"/>
+        <a:font script="Hant" typeface="新細明體"/>
+        <a:font script="Arab" typeface="Arial"/>
+        <a:font script="Hebr" typeface="Arial"/>
+        <a:font script="Thai" typeface="Cordia New"/>
+        <a:font script="Ethi" typeface="Nyala"/>
+        <a:font script="Beng" typeface="Vrinda"/>
+        <a:font script="Gujr" typeface="Shruti"/>
+        <a:font script="Khmr" typeface="DaunPenh"/>
+        <a:font script="Knda" typeface="Tunga"/>
+        <a:font script="Guru" typeface="Raavi"/>
+        <a:font script="Cans" typeface="Euphemia"/>
+        <a:font script="Cher" typeface="Plantagenet Cherokee"/>
+        <a:font script="Yiii" typeface="Microsoft Yi Baiti"/>
+        <a:font script="Tibt" typeface="Microsoft Himalaya"/>
+        <a:font script="Thaa" typeface="MV Boli"/>
+        <a:font script="Deva" typeface="Mangal"/>
+        <a:font script="Telu" typeface="Gautami"/>
+        <a:font script="Taml" typeface="Latha"/>
+        <a:font script="Syrc" typeface="Estrangelo Edessa"/>
+        <a:font script="Orya" typeface="Kalinga"/>
+        <a:font script="Mlym" typeface="Kartika"/>
+        <a:font script="Laoo" typeface="DokChampa"/>
+        <a:font script="Sinh" typeface="Iskoola Pota"/>
+        <a:font script="Mong" typeface="Mongolian Baiti"/>
+        <a:font script="Viet" typeface="Arial"/>
+        <a:font script="Uigh" typeface="Microsoft Uighur"/>
+        <a:font script="Geor" typeface="Sylfaen"/>
+      </a:minorFont>
+    </a:fontScheme>
+    <a:fmtScheme name="Office">
+      <a:fillStyleLst>
+        <a:solidFill>
+          <a:schemeClr val="phClr"/>
+        </a:solidFill>
+        <a:gradFill rotWithShape="1">
+          <a:gsLst>
+            <a:gs pos="0">
+              <a:schemeClr val="phClr">
+                <a:tint val="50000"/>
+                <a:satMod val="300000"/>
+              </a:schemeClr>
+            </a:gs>
+            <a:gs pos="35000">
+              <a:schemeClr val="phClr">
+                <a:tint val="37000"/>
+                <a:satMod val="300000"/>
+              </a:schemeClr>
+            </a:gs>
+            <a:gs pos="100000">
+              <a:schemeClr val="phClr">
+                <a:tint val="15000"/>
+                <a:satMod val="350000"/>
+              </a:schemeClr>
+            </a:gs>
+          </a:gsLst>
+          <a:lin ang="16200000" scaled="1"/>
+        </a:gradFill>
+        <a:gradFill rotWithShape="1">
+          <a:gsLst>
+            <a:gs pos="0">
+              <a:schemeClr val="phClr">
+                <a:tint val="100000"/>
+                <a:shade val="100000"/>
+                <a:satMod val="130000"/>
+              </a:schemeClr>
+            </a:gs>
+            <a:gs pos="100000">
+              <a:schemeClr val="phClr">
+                <a:tint val="50000"/>
+                <a:shade val="100000"/>
+                <a:satMod val="350000"/>
+              </a:schemeClr>
+            </a:gs>
+          </a:gsLst>
+          <a:lin ang="16200000" scaled="0"/>
+        </a:gradFill>
+      </a:fillStyleLst>
+      <a:lnStyleLst>
+        <a:ln w="9525" cap="flat" cmpd="sng" algn="ctr">
+          <a:solidFill>
+            <a:schemeClr val="phClr">
+              <a:shade val="95000"/>
+              <a:satMod val="105000"/>
+            </a:schemeClr>
+          </a:solidFill>
+          <a:prstDash val="solid"/>
+        </a:ln>
+        <a:ln w="25400" cap="flat" cmpd="sng" algn="ctr">
+          <a:solidFill>
+            <a:schemeClr val="phClr"/>
+          </a:solidFill>
+          <a:prstDash val="solid"/>
+        </a:ln>
+        <a:ln w="38100" cap="flat" cmpd="sng" algn="ctr">
+          <a:solidFill>
+            <a:schemeClr val="phClr"/>
+          </a:solidFill>
+          <a:prstDash val="solid"/>
+        </a:ln>
+      </a:lnStyleLst>
+      <a:effectStyleLst>
+        <a:effectStyle>
+          <a:effectLst>
+            <a:outerShdw blurRad="40000" dist="20000" dir="5400000" rotWithShape="0">
+              <a:srgbClr val="000000">
+                <a:alpha val="38000"/>
+              </a:srgbClr>
+            </a:outerShdw>
+          </a:effectLst>
+        </a:effectStyle>
+        <a:effectStyle>
+          <a:effectLst>
+            <a:outerShdw blurRad="40000" dist="23000" dir="5400000" rotWithShape="0">
+              <a:srgbClr val="000000">
+                <a:alpha val="35000"/>
+              </a:srgbClr>
+            </a:outerShdw>
+          </a:effectLst>
+        </a:effectStyle>
+        <a:effectStyle>
+          <a:effectLst>
+            <a:outerShdw blurRad="40000" dist="23000" dir="5400000" rotWithShape="0">
+              <a:srgbClr val="000000">
+                <a:alpha val="35000"/>
+              </a:srgbClr>
+            </a:outerShdw>
+          </a:effectLst>
+          <a:scene3d>
+            <a:camera prst="orthographicFront">
+              <a:rot lat="0" lon="0" rev="0"/>
+            </a:camera>
+            <a:lightRig rig="threePt" dir="t">
+              <a:rot lat="0" lon="0" rev="1200000"/>
+            </a:lightRig>
+          </a:scene3d>
+          <a:sp3d>
+            <a:bevelT w="63500" h="25400"/>
+          </a:sp3d>
+        </a:effectStyle>
+      </a:effectStyleLst>
+      <a:bgFillStyleLst>
+        <a:solidFill>
+          <a:schemeClr val="phClr"/>
+        </a:solidFill>
+        <a:gradFill rotWithShape="1">
+          <a:gsLst>
+            <a:gs pos="0">
+              <a:schemeClr val="phClr">
+                <a:tint val="40000"/>
+                <a:satMod val="350000"/>
+              </a:schemeClr>
+            </a:gs>
+            <a:gs pos="40000">
+              <a:schemeClr val="phClr">
+                <a:tint val="45000"/>
+                <a:shade val="99000"/>
+                <a:satMod val="350000"/>
+              </a:schemeClr>
+            </a:gs>
+            <a:gs pos="100000">
+              <a:schemeClr val="phClr">
+                <a:shade val="20000"/>
+                <a:satMod val="255000"/>
+              </a:schemeClr>
+            </a:gs>
+          </a:gsLst>
+          <a:path path="circle">
+            <a:fillToRect l="50000" t="-80000" r="50000" b="180000"/>
+          </a:path>
+        </a:gradFill>
+        <a:gradFill rotWithShape="1">
+          <a:gsLst>
+            <a:gs pos="0">
+              <a:schemeClr val="phClr">
+                <a:tint val="80000"/>
+                <a:satMod val="300000"/>
+              </a:schemeClr>
+            </a:gs>
+            <a:gs pos="100000">
+              <a:schemeClr val="phClr">
+                <a:shade val="30000"/>
+                <a:satMod val="200000"/>
+              </a:schemeClr>
+            </a:gs>
+          </a:gsLst>
+          <a:path path="circle">
+            <a:fillToRect l="50000" t="50000" r="50000" b="50000"/>
+          </a:path>
+        </a:gradFill>
+      </a:bgFillStyleLst>
+    </a:fmtScheme>
+  </a:themeElements>
+  <a:objectDefaults>
+    <a:spDef>
+      <a:spPr/>
+      <a:bodyPr/>
+      <a:lstStyle/>
+      <a:style>
+        <a:lnRef idx="1">
+          <a:schemeClr val="accent1"/>
+        </a:lnRef>
+        <a:fillRef idx="3">
+          <a:schemeClr val="accent1"/>
+        </a:fillRef>
+        <a:effectRef idx="2">
+          <a:schemeClr val="accent1"/>
+        </a:effectRef>
+        <a:fontRef idx="minor">
+          <a:schemeClr val="lt1"/>
+        </a:fontRef>
+      </a:style>
+    </a:spDef>
+    <a:lnDef>
+      <a:spPr/>
+      <a:bodyPr/>
+      <a:lstStyle/>
+      <a:style>
+        <a:lnRef idx="2">
+          <a:schemeClr val="accent1"/>
+        </a:lnRef>
+        <a:fillRef idx="0">
+          <a:schemeClr val="accent1"/>
+        </a:fillRef>
+        <a:effectRef idx="1">
+          <a:schemeClr val="accent1"/>
+        </a:effectRef>
+        <a:fontRef idx="minor">
+          <a:schemeClr val="tx1"/>
+        </a:fontRef>
+      </a:style>
+    </a:lnDef>
+  </a:objectDefaults>
+  <a:extraClrSchemeLst/>
+</a:theme>
 </file>
</xml_diff>

<commit_message>
Slide notes: 45-second talk track
Co-Authored-By: Claude Opus 5.5 (1M context) <noreply@anthropic.com>
</commit_message>
<xml_diff>
--- a/docs/slides/output-quality-demo-intro.pptx
+++ b/docs/slides/output-quality-demo-intro.pptx
@@ -502,43 +502,58 @@
           <a:lstStyle/>
           <a:p>
             <a:r>
-              <a:t>OPENING — AI agents now answer users directly. Most guardrails look at what goes INTO the model (the prompt); very few check what comes OUT. Was the answer true? Fair? On topic? This policy checks every answer on the gateway, before it reaches the user, with no change to the agent.</a:t>
+              <a:t>TALK TRACK (~45 s)</a:t>
+            </a:r>
+          </a:p>
+          <a:p>
+            <a:r>
+              <a:t>AI agents now answer users directly, but most guardrails only check the prompt, not the answer.</a:t>
+            </a:r>
+          </a:p>
+          <a:p>
+            <a:r>
+              <a:t>This policy runs on Omni Gateway, between the gateway and the agent, and checks every answer before the user sees it. No change to the agent.</a:t>
+            </a:r>
+          </a:p>
+          <a:p>
+            <a:r>
+              <a:t>A separate AI judge scores each answer for hallucination, toxicity, bias and anomaly. If the judge is down, a red-flag word list takes over, and checks for broken output and user thumbs-down always run.</a:t>
+            </a:r>
+          </a:p>
+          <a:p>
+            <a:r>
+              <a:t>Per risk, you choose: pass it, annotate it with a warning, or block it.</a:t>
+            </a:r>
+          </a:p>
+          <a:p>
+            <a:r>
+              <a:t>In our live run, each verdict took one to two and a half seconds.</a:t>
+            </a:r>
+          </a:p>
+          <a:p>
+            <a:r>
+              <a:t>The bad answers you'll see are scripted, but the judge is real. Let's look.</a:t>
             </a:r>
           </a:p>
           <a:p/>
           <a:p>
             <a:r>
-              <a:t>01 WHERE IT RUNS — Omni Gateway, as an outbound policy: between the gateway and the agent, so it sees exactly what the agent sent back. For each reply the gateway asks a separate AI (OpenAI gpt-5.4) to judge it. The agent uses a smaller model, so it's never marking its own homework.</a:t>
-            </a:r>
-          </a:p>
-          <a:p/>
-          <a:p>
-            <a:r>
-              <a:t>02 HOW IT DECIDES — Three layers. (1) The LLM judge reads the user's question and the answer and scores 0-1 for hallucination, toxicity, bias and anomaly (off-topic, leaked instructions). (2) If the judge is slow or down, a backup checklist of red-flag words takes over; cruder, but traffic never waits. (3) Always-on checks: empty, cut-off or looping answers, failed tasks, and users' thumbs-down; if many users complain, every answer gets flagged.</a:t>
-            </a:r>
-          </a:p>
-          <a:p/>
-          <a:p>
-            <a:r>
-              <a:t>03 WHAT IT DOES — Your choice per risk: PASS clean answers, ANNOTATE (deliver with a quality report the app can use to warn the user), or BLOCK (withhold the answer). Start by monitoring, tighten one category at a time. Every flag is logged by the gateway and reported in the response.</a:t>
-            </a:r>
-          </a:p>
-          <a:p/>
-          <a:p>
-            <a:r>
-              <a:t>NUMBERS — Live run on CloudHub 2.0: 1-2.5 s per verdict, 4 risk categories, A2A v0.3 and v1.0 plus OpenAI/Anthropic-style APIs, 102 automated tests.</a:t>
-            </a:r>
-          </a:p>
-          <a:p/>
-          <a:p>
-            <a:r>
-              <a:t>TRANSITION — Honesty note: the bad answers in the demo are scripted (today's models won't misbehave on cue). The judge is real, and so is every verdict. Let's look.</a:t>
-            </a:r>
-          </a:p>
-          <a:p/>
-          <a:p>
-            <a:r>
-              <a:t>IF ASKED — Monitoring: request volume and latency yes; flags are in gateway logs and the response report, outbound violation counts aren't in Monitoring yet. LLM traffic: the policy reads OpenAI and Anthropic formats; the live demo uses an A2A agent, the LLM-API path is lab-tested. Latency: ~1-2.5 s with the judge on every answer; near zero for clean traffic with judgeMode onSuspicion.</a:t>
+              <a:t>IF ASKED</a:t>
+            </a:r>
+          </a:p>
+          <a:p>
+            <a:r>
+              <a:t>- Monitoring: request volume and latency yes; flags are in gateway logs and the response report (outbound violation counts aren't in Monitoring yet).</a:t>
+            </a:r>
+          </a:p>
+          <a:p>
+            <a:r>
+              <a:t>- LLM traffic: reads OpenAI and Anthropic formats; today's demo uses an A2A agent, the LLM-API path is lab-tested.</a:t>
+            </a:r>
+          </a:p>
+          <a:p>
+            <a:r>
+              <a:t>- Latency: ~1-2.5 s with the judge on every answer; near zero for clean traffic with judgeMode onSuspicion.</a:t>
             </a:r>
           </a:p>
         </p:txBody>

</xml_diff>

<commit_message>
Slide: accurate action wording (log / annotate / block) in notes and Pass row
The per-category actions in the code are monitor, annotate and block; clean
answers always pass. Talk track and the Pass caption now say so.

Co-Authored-By: Claude Opus 5.5 (1M context) <noreply@anthropic.com>
</commit_message>
<xml_diff>
--- a/docs/slides/output-quality-demo-intro.pptx
+++ b/docs/slides/output-quality-demo-intro.pptx
@@ -522,7 +522,7 @@
           </a:p>
           <a:p>
             <a:r>
-              <a:t>Per risk, you choose: pass it, annotate it with a warning, or block it.</a:t>
+              <a:t>Per risk, you choose what happens to a flagged answer: log it, annotate it with a warning, or block it.</a:t>
             </a:r>
           </a:p>
           <a:p>
@@ -5017,7 +5017,7 @@
                 </a:solidFill>
                 <a:latin typeface="Salesforce Sans"/>
               </a:rPr>
-              <a:t>Clean answers flow untouched</a:t>
+              <a:t>Clean, or flagged and set to monitor</a:t>
             </a:r>
           </a:p>
         </p:txBody>

</xml_diff>